<commit_message>
Logo de l'université sur tous les documents de cours
Supports de cours, séries de TD (énoncés et corrigés), fascicule de TP et
diaporamas (PowerPoint et PDF) : logo USNM en page de garde et sur les
diapositives de titre et de fin. La version Labo virtuel n'est pas modifiée.

Co-Authored-By: Claude Opus 5.5 <noreply@anthropic.com>
Claude-Session: https://claude.ai/code/session_016e4mvVAHkX2phRmUpAeQE1
</commit_message>
<xml_diff>
--- a/slides/Electricite2_Chapitre_1_Champ_magnetique.pptx
+++ b/slides/Electricite2_Chapitre_1_Champ_magnetique.pptx
@@ -5514,6 +5514,78 @@
           </a:p>
         </p:txBody>
       </p:sp>
+      <p:sp>
+        <p:nvSpPr>
+          <p:cNvPr id="70" name="Logo USNM (cadre)"/>
+          <p:cNvSpPr/>
+          <p:nvPr/>
+        </p:nvSpPr>
+        <p:spPr>
+          <a:xfrm>
+            <a:off x="10378440" y="384048"/>
+            <a:ext cx="1371600" cy="1371600"/>
+          </a:xfrm>
+          <a:prstGeom prst="roundRect">
+            <a:avLst>
+              <a:gd name="adj" fmla="val 10000"/>
+            </a:avLst>
+          </a:prstGeom>
+          <a:solidFill>
+            <a:srgbClr val="FFFFFF"/>
+          </a:solidFill>
+          <a:ln w="15875">
+            <a:solidFill>
+              <a:srgbClr val="D98E04"/>
+            </a:solidFill>
+          </a:ln>
+          <a:effectLst/>
+        </p:spPr>
+        <p:style>
+          <a:lnRef idx="1">
+            <a:schemeClr val="accent1"/>
+          </a:lnRef>
+          <a:fillRef idx="3">
+            <a:schemeClr val="accent1"/>
+          </a:fillRef>
+          <a:effectRef idx="2">
+            <a:schemeClr val="accent1"/>
+          </a:effectRef>
+          <a:fontRef idx="minor">
+            <a:schemeClr val="lt1"/>
+          </a:fontRef>
+        </p:style>
+        <p:txBody>
+          <a:bodyPr rtlCol="0" anchor="ctr"/>
+          <a:lstStyle/>
+          <a:p>
+            <a:pPr algn="ctr"/>
+          </a:p>
+        </p:txBody>
+      </p:sp>
+      <p:pic>
+        <p:nvPicPr>
+          <p:cNvPr id="71" name="Logo Université Souleymane Niang de Matam" descr="usnm-logo-hd.jpg"/>
+          <p:cNvPicPr>
+            <a:picLocks noChangeAspect="1"/>
+          </p:cNvPicPr>
+          <p:nvPr/>
+        </p:nvPicPr>
+        <p:blipFill>
+          <a:blip r:embed="rId3"/>
+          <a:stretch>
+            <a:fillRect/>
+          </a:stretch>
+        </p:blipFill>
+        <p:spPr>
+          <a:xfrm>
+            <a:off x="10469880" y="475488"/>
+            <a:ext cx="1188720" cy="1188720"/>
+          </a:xfrm>
+          <a:prstGeom prst="rect">
+            <a:avLst/>
+          </a:prstGeom>
+        </p:spPr>
+      </p:pic>
     </p:spTree>
   </p:cSld>
   <p:clrMapOvr>
@@ -11569,6 +11641,78 @@
           </a:p>
         </p:txBody>
       </p:sp>
+      <p:sp>
+        <p:nvSpPr>
+          <p:cNvPr id="54" name="Logo USNM (cadre)"/>
+          <p:cNvSpPr/>
+          <p:nvPr/>
+        </p:nvSpPr>
+        <p:spPr>
+          <a:xfrm>
+            <a:off x="10378440" y="384048"/>
+            <a:ext cx="1371600" cy="1371600"/>
+          </a:xfrm>
+          <a:prstGeom prst="roundRect">
+            <a:avLst>
+              <a:gd name="adj" fmla="val 10000"/>
+            </a:avLst>
+          </a:prstGeom>
+          <a:solidFill>
+            <a:srgbClr val="FFFFFF"/>
+          </a:solidFill>
+          <a:ln w="15875">
+            <a:solidFill>
+              <a:srgbClr val="D98E04"/>
+            </a:solidFill>
+          </a:ln>
+          <a:effectLst/>
+        </p:spPr>
+        <p:style>
+          <a:lnRef idx="1">
+            <a:schemeClr val="accent1"/>
+          </a:lnRef>
+          <a:fillRef idx="3">
+            <a:schemeClr val="accent1"/>
+          </a:fillRef>
+          <a:effectRef idx="2">
+            <a:schemeClr val="accent1"/>
+          </a:effectRef>
+          <a:fontRef idx="minor">
+            <a:schemeClr val="lt1"/>
+          </a:fontRef>
+        </p:style>
+        <p:txBody>
+          <a:bodyPr rtlCol="0" anchor="ctr"/>
+          <a:lstStyle/>
+          <a:p>
+            <a:pPr algn="ctr"/>
+          </a:p>
+        </p:txBody>
+      </p:sp>
+      <p:pic>
+        <p:nvPicPr>
+          <p:cNvPr id="55" name="Logo Université Souleymane Niang de Matam" descr="usnm-logo-hd.jpg"/>
+          <p:cNvPicPr>
+            <a:picLocks noChangeAspect="1"/>
+          </p:cNvPicPr>
+          <p:nvPr/>
+        </p:nvPicPr>
+        <p:blipFill>
+          <a:blip r:embed="rId3"/>
+          <a:stretch>
+            <a:fillRect/>
+          </a:stretch>
+        </p:blipFill>
+        <p:spPr>
+          <a:xfrm>
+            <a:off x="10469880" y="475488"/>
+            <a:ext cx="1188720" cy="1188720"/>
+          </a:xfrm>
+          <a:prstGeom prst="rect">
+            <a:avLst/>
+          </a:prstGeom>
+        </p:spPr>
+      </p:pic>
     </p:spTree>
   </p:cSld>
   <p:clrMapOvr>

</xml_diff>